<commit_message>
Added the git hub link in the last slide of the pptx and pdf deck
</commit_message>
<xml_diff>
--- a/PitchbookDeck_and_deliverables/Private_Markets_Analytics_Pipeline.pptx
+++ b/PitchbookDeck_and_deliverables/Private_Markets_Analytics_Pipeline.pptx
@@ -1775,7 +1775,7 @@
           <a:p>
             <a:fld id="{37A2730A-859E-B540-ADF3-E97069AD1FDB}" type="datetimeFigureOut">
               <a:rPr lang="en-US" smtClean="0"/>
-              <a:t>5/10/2026</a:t>
+              <a:t>5/11/2026</a:t>
             </a:fld>
             <a:endParaRPr lang="en-US"/>
           </a:p>
@@ -14868,8 +14868,8 @@
           <a:noFill/>
         </p:spPr>
       </p:pic>
-      <mc:AlternateContent xmlns:mc="http://schemas.openxmlformats.org/markup-compatibility/2006">
-        <mc:Choice xmlns:we="http://schemas.microsoft.com/office/webextensions/webextension/2010/11" xmlns:pca="http://schemas.microsoft.com/office/powerpoint/2013/contentapp" Requires="we pca">
+      <mc:AlternateContent xmlns:mc="http://schemas.openxmlformats.org/markup-compatibility/2006" xmlns:we="http://schemas.microsoft.com/office/webextensions/webextension/2010/11" xmlns:pca="http://schemas.microsoft.com/office/powerpoint/2013/contentapp">
+        <mc:Choice Requires="we pca">
           <p:graphicFrame>
             <p:nvGraphicFramePr>
               <p:cNvPr id="2" name="Add-in" descr="Add-in content for Microsoft Power BI."/>
@@ -14889,7 +14889,7 @@
             </a:graphic>
           </p:graphicFrame>
         </mc:Choice>
-        <mc:Fallback>
+        <mc:Fallback xmlns="">
           <p:pic>
             <p:nvPicPr>
               <p:cNvPr id="2" name="Add-in" descr="Add-in content for Microsoft Power BI."/>
@@ -15053,8 +15053,8 @@
           <a:noFill/>
         </p:spPr>
       </p:pic>
-      <mc:AlternateContent xmlns:mc="http://schemas.openxmlformats.org/markup-compatibility/2006">
-        <mc:Choice xmlns:we="http://schemas.microsoft.com/office/webextensions/webextension/2010/11" xmlns:pca="http://schemas.microsoft.com/office/powerpoint/2013/contentapp" Requires="we pca">
+      <mc:AlternateContent xmlns:mc="http://schemas.openxmlformats.org/markup-compatibility/2006" xmlns:we="http://schemas.microsoft.com/office/webextensions/webextension/2010/11" xmlns:pca="http://schemas.microsoft.com/office/powerpoint/2013/contentapp">
+        <mc:Choice Requires="we pca">
           <p:graphicFrame>
             <p:nvGraphicFramePr>
               <p:cNvPr id="2" name="Add-in" descr="Add-in content for Microsoft Power BI."/>
@@ -15074,7 +15074,7 @@
             </a:graphic>
           </p:graphicFrame>
         </mc:Choice>
-        <mc:Fallback>
+        <mc:Fallback xmlns="">
           <p:pic>
             <p:nvPicPr>
               <p:cNvPr id="2" name="Add-in" descr="Add-in content for Microsoft Power BI."/>
@@ -18290,9 +18290,6 @@
           <a:bodyPr wrap="square" rtlCol="0" anchor="ctr"/>
           <a:lstStyle/>
           <a:p>
-            <a:pPr marL="0" indent="0">
-              <a:buNone/>
-            </a:pPr>
             <a:r>
               <a:rPr lang="en-US" sz="1300" dirty="0">
                 <a:solidFill>
@@ -18302,7 +18299,30 @@
                 <a:ea typeface="Calibri" pitchFamily="34" charset="-122"/>
                 <a:cs typeface="Calibri" pitchFamily="34" charset="-120"/>
               </a:rPr>
-              <a:t>The pipeline, dbt models, SQL transformation files, validation scripts, and Power BI reports are available for review at git hub link</a:t>
+              <a:t>The pipeline, dbt models, SQL transformation files, validation scripts, and Power BI reports are available for review at git hub link : </a:t>
+            </a:r>
+            <a:r>
+              <a:rPr lang="en-US" sz="1300" dirty="0">
+                <a:solidFill>
+                  <a:srgbClr val="CADCFC"/>
+                </a:solidFill>
+                <a:latin typeface="Calibri" pitchFamily="34" charset="0"/>
+                <a:ea typeface="Calibri" pitchFamily="34" charset="-122"/>
+                <a:cs typeface="Calibri" pitchFamily="34" charset="-120"/>
+                <a:hlinkClick r:id="rId3"/>
+              </a:rPr>
+              <a:t>https://github.com/gny-analytics/Private_Markets_Analytics_Pipeline</a:t>
+            </a:r>
+            <a:r>
+              <a:rPr lang="en-US" sz="1300" dirty="0">
+                <a:solidFill>
+                  <a:srgbClr val="CADCFC"/>
+                </a:solidFill>
+                <a:latin typeface="Calibri" pitchFamily="34" charset="0"/>
+                <a:ea typeface="Calibri" pitchFamily="34" charset="-122"/>
+                <a:cs typeface="Calibri" pitchFamily="34" charset="-120"/>
+              </a:rPr>
+              <a:t> </a:t>
             </a:r>
             <a:endParaRPr lang="en-US" sz="1300" dirty="0"/>
           </a:p>

</xml_diff>

<commit_message>
resaved pptx and pdf deck
</commit_message>
<xml_diff>
--- a/PitchbookDeck_and_deliverables/Private_Markets_Analytics_Pipeline.pptx
+++ b/PitchbookDeck_and_deliverables/Private_Markets_Analytics_Pipeline.pptx
@@ -14868,8 +14868,8 @@
           <a:noFill/>
         </p:spPr>
       </p:pic>
-      <mc:AlternateContent xmlns:mc="http://schemas.openxmlformats.org/markup-compatibility/2006" xmlns:we="http://schemas.microsoft.com/office/webextensions/webextension/2010/11" xmlns:pca="http://schemas.microsoft.com/office/powerpoint/2013/contentapp">
-        <mc:Choice Requires="we pca">
+      <mc:AlternateContent xmlns:mc="http://schemas.openxmlformats.org/markup-compatibility/2006">
+        <mc:Choice xmlns:we="http://schemas.microsoft.com/office/webextensions/webextension/2010/11" xmlns:pca="http://schemas.microsoft.com/office/powerpoint/2013/contentapp" Requires="we pca">
           <p:graphicFrame>
             <p:nvGraphicFramePr>
               <p:cNvPr id="2" name="Add-in" descr="Add-in content for Microsoft Power BI."/>
@@ -14889,7 +14889,7 @@
             </a:graphic>
           </p:graphicFrame>
         </mc:Choice>
-        <mc:Fallback xmlns="">
+        <mc:Fallback>
           <p:pic>
             <p:nvPicPr>
               <p:cNvPr id="2" name="Add-in" descr="Add-in content for Microsoft Power BI."/>
@@ -15053,8 +15053,8 @@
           <a:noFill/>
         </p:spPr>
       </p:pic>
-      <mc:AlternateContent xmlns:mc="http://schemas.openxmlformats.org/markup-compatibility/2006" xmlns:we="http://schemas.microsoft.com/office/webextensions/webextension/2010/11" xmlns:pca="http://schemas.microsoft.com/office/powerpoint/2013/contentapp">
-        <mc:Choice Requires="we pca">
+      <mc:AlternateContent xmlns:mc="http://schemas.openxmlformats.org/markup-compatibility/2006">
+        <mc:Choice xmlns:we="http://schemas.microsoft.com/office/webextensions/webextension/2010/11" xmlns:pca="http://schemas.microsoft.com/office/powerpoint/2013/contentapp" Requires="we pca">
           <p:graphicFrame>
             <p:nvGraphicFramePr>
               <p:cNvPr id="2" name="Add-in" descr="Add-in content for Microsoft Power BI."/>
@@ -15074,7 +15074,7 @@
             </a:graphic>
           </p:graphicFrame>
         </mc:Choice>
-        <mc:Fallback xmlns="">
+        <mc:Fallback>
           <p:pic>
             <p:nvPicPr>
               <p:cNvPr id="2" name="Add-in" descr="Add-in content for Microsoft Power BI."/>

</xml_diff>